<commit_message>
Add approval settings reference, update project knowledge with chat.tools.* keys
</commit_message>
<xml_diff>
--- a/pptx-output/02-setup-github-copilot-agents.pptx
+++ b/pptx-output/02-setup-github-copilot-agents.pptx
@@ -531,7 +531,7 @@
           </a:p>
           <a:p>
             <a:r>
-              <a:t>Assume learners already know the module 01 baseline: Ask, Plan, Agent, then review. This module turns that behavior model into actual product readiness and prepares them for module 03 prompt work.</a:t>
+              <a:t>Assume learners already know the module 01 baseline: Ask, Edit, Plan, Agent, then review. This module turns that behavior model into actual product readiness and prepares them for module 03 prompt work.</a:t>
             </a:r>
           </a:p>
         </p:txBody>
@@ -7513,7 +7513,7 @@
                 </a:solidFill>
                 <a:latin typeface="Segoe UI"/>
               </a:rPr>
-              <a:t>Confirm Ask, Plan, and Agent availability</a:t>
+              <a:t>Confirm Ask, Edit, Plan, and Agent availability</a:t>
             </a:r>
           </a:p>
           <a:p>
@@ -8114,7 +8114,7 @@
                 </a:solidFill>
                 <a:latin typeface="Segoe UI"/>
               </a:rPr>
-              <a:t>Learner can identify Ask, Plan, and Agent or explain why unavailable</a:t>
+              <a:t>Learner can identify Ask, Edit, Plan, and Agent or explain why unavailable</a:t>
             </a:r>
           </a:p>
           <a:p>
@@ -10165,7 +10165,7 @@
                 </a:solidFill>
                 <a:latin typeface="Segoe UI"/>
               </a:rPr>
-              <a:t>Assume learners already know the module 01 baseline: Ask, Plan, Agent, then review. This module turns that behavior model into actual product readiness and prepares them for module 03 prompt work.</a:t>
+              <a:t>Assume learners already know the module 01 baseline: Ask, Edit, Plan, Agent, then review. This module turns that behavior model into actual product readiness and prepares them for module 03 prompt work.</a:t>
             </a:r>
           </a:p>
         </p:txBody>
@@ -10793,7 +10793,7 @@
                 </a:solidFill>
                 <a:latin typeface="Segoe UI"/>
               </a:rPr>
-              <a:t>Start a first safe session using Ask, Plan, then Agent</a:t>
+              <a:t>Start a first safe session using Ask, Edit, Plan, then Agent</a:t>
             </a:r>
           </a:p>
           <a:p>
@@ -13768,7 +13768,7 @@
                 </a:solidFill>
                 <a:latin typeface="Segoe UI"/>
               </a:rPr>
-              <a:t>Look for Ask, Plan, and Agent</a:t>
+              <a:t>Look for Ask, Edit, Plan, and Agent</a:t>
             </a:r>
           </a:p>
           <a:p>

</xml_diff>